<commit_message>
Enforce local-only dataset custody — replace bucket/NDA wording
The dataset must never leave the project lead's workstation. Replace
all references to a "NDA bucket" or shared distribution in the
executive deck and add an explicit storage policy.

- docs/dataset-storage-policy.md: new policy doc with authoritative
  local paths, forbidden actions (no commit, no cloud, no shared, no
  Hugging Face, no Docker bake, no Slack/Drive), workstation hardening
  checklist (iCloud off, FileVault on, no Drive sync), incident
  handling per GDPR Art. 33, decommission/erase procedure.
- build_deliverables_pptx.js + IntellIntents_Deliverables_v1.pptx:
  slide 2 card D1 reworded to "Custodia: solo local · no nube · no
  compartido"; slide 2 footer reworded to custody policy; slide 4
  risk #1 mitigation reworded; slide 5 action 04 retitled "Firmar
  política de custodia"; slide 5 git card shows "3.4 GB · solo local
  · NO COMMIT".

Co-Authored-By: Claude Opus 4.7 (1M context) <noreply@anthropic.com>
</commit_message>
<xml_diff>
--- a/IntellIntents_Deliverables_v1.pptx
+++ b/IntellIntents_Deliverables_v1.pptx
@@ -3014,7 +3014,7 @@
                 <a:ea typeface="Calibri" pitchFamily="34" charset="-122"/>
                 <a:cs typeface="Calibri" pitchFamily="34" charset="-120"/>
               </a:rPr>
-              <a:t>Distribución: bucket privado NDA (no público)</a:t>
+              <a:t>Custodia: solo local · no nube · no compartido</a:t>
             </a:r>
             <a:endParaRPr lang="en-US" sz="1100" dirty="0"/>
           </a:p>
@@ -3078,7 +3078,7 @@
                 <a:ea typeface="Calibri" pitchFamily="34" charset="-122"/>
                 <a:cs typeface="Calibri" pitchFamily="34" charset="-120"/>
               </a:rPr>
-              <a:t>Existe · pendiente datasheet + manifest</a:t>
+              <a:t>Existe · custodia única en workstation del lead</a:t>
             </a:r>
             <a:endParaRPr lang="en-US" sz="1000" dirty="0"/>
           </a:p>
@@ -4339,7 +4339,7 @@
                 <a:ea typeface="Calibri" pitchFamily="34" charset="-122"/>
                 <a:cs typeface="Calibri" pitchFamily="34" charset="-120"/>
               </a:rPr>
-              <a:t>Distribución del dataset: solo bajo NDA — confirmado por sponsor (16-may-2026)</a:t>
+              <a:t>Política de custodia: el dataset permanece local en la workstation del project lead — no commit, no cloud, no shared (16-may-2026)</a:t>
             </a:r>
             <a:endParaRPr lang="en-US" sz="1000" dirty="0"/>
           </a:p>
@@ -6338,7 +6338,7 @@
                 <a:ea typeface="Calibri" pitchFamily="34" charset="-122"/>
                 <a:cs typeface="Calibri" pitchFamily="34" charset="-120"/>
               </a:rPr>
-              <a:t>Bucket privado NDA · redacción · datasheet explícito</a:t>
+              <a:t>Custodia local exclusiva · sin sync cloud · política firmada</a:t>
             </a:r>
             <a:endParaRPr lang="en-US" sz="1000" dirty="0"/>
           </a:p>
@@ -7378,7 +7378,7 @@
                 <a:ea typeface="Calibri" pitchFamily="34" charset="-122"/>
                 <a:cs typeface="Calibri" pitchFamily="34" charset="-120"/>
               </a:rPr>
-              <a:t>Aprobar bucket NDA</a:t>
+              <a:t>Firmar política de custodia</a:t>
             </a:r>
             <a:endParaRPr lang="en-US" sz="1400" dirty="0"/>
           </a:p>
@@ -7417,7 +7417,7 @@
                 <a:ea typeface="Calibri" pitchFamily="34" charset="-122"/>
                 <a:cs typeface="Calibri" pitchFamily="34" charset="-120"/>
               </a:rPr>
-              <a:t>Legal confirma acceso al corpus completo + hashes SHA-256 del manifest.</a:t>
+              <a:t>Legal/DPO valida docs/dataset-storage-policy.md · checklist §5 ejecutado en la workstation.</a:t>
             </a:r>
             <a:endParaRPr lang="en-US" sz="1050" dirty="0"/>
           </a:p>
@@ -8207,7 +8207,7 @@
                 <a:ea typeface="Calibri" pitchFamily="34" charset="-122"/>
                 <a:cs typeface="Calibri" pitchFamily="34" charset="-120"/>
               </a:rPr>
-              <a:t>DATASET JSON</a:t>
+              <a:t>DATASET</a:t>
             </a:r>
             <a:endParaRPr lang="en-US" sz="900" dirty="0"/>
           </a:p>
@@ -8246,7 +8246,7 @@
                 <a:ea typeface="Calibri" pitchFamily="34" charset="-122"/>
                 <a:cs typeface="Calibri" pitchFamily="34" charset="-120"/>
               </a:rPr>
-              <a:t>1.4 GB → bucket NDA</a:t>
+              <a:t>3.4 GB · solo local</a:t>
             </a:r>
             <a:endParaRPr lang="en-US" sz="1100" dirty="0"/>
           </a:p>
@@ -8310,7 +8310,7 @@
                 <a:ea typeface="Calibri" pitchFamily="34" charset="-122"/>
                 <a:cs typeface="Calibri" pitchFamily="34" charset="-120"/>
               </a:rPr>
-              <a:t>EXCLUIDOS</a:t>
+              <a:t>NO COMMIT</a:t>
             </a:r>
             <a:endParaRPr lang="en-US" sz="800" dirty="0"/>
           </a:p>

</xml_diff>